<commit_message>
Deck: nine slides, updated for twin-builder subagent, prompt log and acceptance-criteria brief
Co-Authored-By: Claude Fable 5.1 <noreply@anthropic.com>
Claude-Session: https://claude.ai/code/session_015m67GH5kmGFeVhFqEPHiN8
</commit_message>
<xml_diff>
--- a/demo/minimal-twin.pptx
+++ b/demo/minimal-twin.pptx
@@ -14,10 +14,9 @@
     <p:sldId id="262" r:id="rId8"/>
     <p:sldId id="263" r:id="rId9"/>
     <p:sldId id="264" r:id="rId10"/>
-    <p:sldId id="265" r:id="rId11"/>
   </p:sldIdLst>
   <p:notesMasterIdLst>
-    <p:notesMasterId r:id="rId12"/>
+    <p:notesMasterId r:id="rId11"/>
   </p:notesMasterIdLst>
   <p:sldSz cx="12192000" cy="6858000"/>
   <p:notesSz cx="6858000" cy="12192000"/>
@@ -553,94 +552,6 @@
 </p:notes>
 </file>
 
-<file path=ppt/notesSlides/notesSlide10.xml><?xml version="1.0" encoding="utf-8"?>
-<p:notes xmlns:a="http://schemas.openxmlformats.org/drawingml/2006/main" xmlns:r="http://schemas.openxmlformats.org/officeDocument/2006/relationships" xmlns:p="http://schemas.openxmlformats.org/presentationml/2006/main">
-  <p:cSld>
-    <p:spTree>
-      <p:nvGrpSpPr>
-        <p:cNvPr id="1" name=""/>
-        <p:cNvGrpSpPr/>
-        <p:nvPr/>
-      </p:nvGrpSpPr>
-      <p:grpSpPr>
-        <a:xfrm>
-          <a:off x="0" y="0"/>
-          <a:ext cx="0" cy="0"/>
-          <a:chOff x="0" y="0"/>
-          <a:chExt cx="0" cy="0"/>
-        </a:xfrm>
-      </p:grpSpPr>
-      <p:sp>
-        <p:nvSpPr>
-          <p:cNvPr id="2" name="Slide Image Placeholder 1"/>
-          <p:cNvSpPr>
-            <a:spLocks noGrp="1" noRot="1" noChangeAspect="1"/>
-          </p:cNvSpPr>
-          <p:nvPr>
-            <p:ph type="sldImg"/>
-          </p:nvPr>
-        </p:nvSpPr>
-        <p:spPr/>
-      </p:sp>
-      <p:sp>
-        <p:nvSpPr>
-          <p:cNvPr id="3" name="Notes Placeholder 2"/>
-          <p:cNvSpPr>
-            <a:spLocks noGrp="1"/>
-          </p:cNvSpPr>
-          <p:nvPr>
-            <p:ph type="body" idx="1"/>
-          </p:nvPr>
-        </p:nvSpPr>
-        <p:spPr/>
-        <p:txBody>
-          <a:bodyPr/>
-          <a:lstStyle/>
-          <a:p>
-            <a:r>
-              <a:rPr lang="en-US" dirty="0"/>
-              <a:t>End here. The point of framing it as an experiment: the reviewer's real question was net value vs context cost, and only data answers that. Offer the calibration run as the first concrete step this week.</a:t>
-            </a:r>
-            <a:endParaRPr lang="en-US" dirty="0"/>
-          </a:p>
-        </p:txBody>
-      </p:sp>
-      <p:sp>
-        <p:nvSpPr>
-          <p:cNvPr id="4" name="Slide Number Placeholder 3"/>
-          <p:cNvSpPr>
-            <a:spLocks noGrp="1"/>
-          </p:cNvSpPr>
-          <p:nvPr>
-            <p:ph type="sldNum" sz="quarter" idx="10"/>
-          </p:nvPr>
-        </p:nvSpPr>
-        <p:spPr/>
-        <p:txBody>
-          <a:bodyPr/>
-          <a:lstStyle/>
-          <a:p>
-            <a:fld id="{F7021451-1387-4CA6-816F-3879F97B5CBC}" type="slidenum">
-              <a:rPr lang="en-US"/>
-              <a:t>10</a:t>
-            </a:fld>
-            <a:endParaRPr lang="en-US"/>
-          </a:p>
-        </p:txBody>
-      </p:sp>
-    </p:spTree>
-    <p:extLst>
-      <p:ext uri="{BB962C8B-B14F-4D97-AF65-F5344CB8AC3E}">
-        <p14:creationId xmlns:p14="http://schemas.microsoft.com/office/powerpoint/2010/main" val="1024086991"/>
-      </p:ext>
-    </p:extLst>
-  </p:cSld>
-  <p:clrMapOvr>
-    <a:masterClrMapping/>
-  </p:clrMapOvr>
-</p:notes>
-</file>
-
 <file path=ppt/notesSlides/notesSlide2.xml><?xml version="1.0" encoding="utf-8"?>
 <p:notes xmlns:a="http://schemas.openxmlformats.org/drawingml/2006/main" xmlns:r="http://schemas.openxmlformats.org/officeDocument/2006/relationships" xmlns:p="http://schemas.openxmlformats.org/presentationml/2006/main">
   <p:cSld>
@@ -863,7 +774,7 @@
           <a:p>
             <a:r>
               <a:rPr lang="en-US" dirty="0"/>
-              <a:t>Linters and PR bots list smells. This produces a measurement: 'this PR is N times its minimal size, and here is what you can delete with nothing breaking.' It is entirely a prompt — a SKILL.md of ~90 lines. Then go live.</a:t>
+              <a:t>Linters and PR bots list smells. This produces a measurement: 'this PR is N times its minimal size, and here is what you can delete with nothing breaking.' Five principles, ~80 lines of markdown, no code. The brief format is what keeps the twin blind — Given/When/Then cannot describe a validator or a builder. Then go live.</a:t>
             </a:r>
             <a:endParaRPr lang="en-US" dirty="0"/>
           </a:p>
@@ -1039,7 +950,7 @@
           <a:p>
             <a:r>
               <a:rPr lang="en-US" dirty="0"/>
-              <a:t>This is verbatim from demo/sample-review.md. The two defects on the right are the persuasive bit: the verbose code created a real bug and a real security surface, and the twin comparison is what surfaced them — the extra code had nowhere to hide.</a:t>
+              <a:t>This is verbatim from demo/sample-review.md. The two defects on the right are the persuasive bit: the verbose code created a real bug and a real security surface, and the twin comparison is what surfaced them — the extra code had nowhere to hide. This run predates the subagent: the twin was built inline before reading the diff. The live run uses twin-builder in isolation, which can only make the comparison fairer.</a:t>
             </a:r>
             <a:endParaRPr lang="en-US" dirty="0"/>
           </a:p>
@@ -1303,7 +1214,7 @@
           <a:p>
             <a:r>
               <a:rPr lang="en-US" dirty="0"/>
-              <a:t>Directly addresses the context-cost concern: the always-on skill is ~60 lines; the twin skill loads on demand.</a:t>
+              <a:t>End here. The point of framing it as an experiment: the reviewer's real question was net value vs context cost, and only data answers that. Offer the calibration run as the first concrete step this week.</a:t>
             </a:r>
             <a:endParaRPr lang="en-US" dirty="0"/>
           </a:p>
@@ -1826,687 +1737,9 @@
                 <a:ea typeface="Calibri" pitchFamily="34" charset="-122"/>
                 <a:cs typeface="Calibri" pitchFamily="34" charset="-120"/>
               </a:rPr>
-              <a:t>258 lines of markdown. No scripts. No CI changes.</a:t>
+              <a:t>~280 lines of markdown. No scripts. No CI changes. Nothing to maintain as the models move.</a:t>
             </a:r>
             <a:endParaRPr lang="en-US" sz="1600" dirty="0"/>
-          </a:p>
-        </p:txBody>
-      </p:sp>
-    </p:spTree>
-  </p:cSld>
-  <p:clrMapOvr>
-    <a:masterClrMapping/>
-  </p:clrMapOvr>
-</p:sld>
-</file>
-
-<file path=ppt/slides/slide10.xml><?xml version="1.0" encoding="utf-8"?>
-<p:sld xmlns:a="http://schemas.openxmlformats.org/drawingml/2006/main" xmlns:r="http://schemas.openxmlformats.org/officeDocument/2006/relationships" xmlns:p="http://schemas.openxmlformats.org/presentationml/2006/main">
-  <p:cSld name="Slide 10">
-    <p:bg>
-      <p:bgPr>
-        <a:solidFill>
-          <a:srgbClr val="1B1F24"/>
-        </a:solidFill>
-      </p:bgPr>
-    </p:bg>
-    <p:spTree>
-      <p:nvGrpSpPr>
-        <p:cNvPr id="1" name=""/>
-        <p:cNvGrpSpPr/>
-        <p:nvPr/>
-      </p:nvGrpSpPr>
-      <p:grpSpPr>
-        <a:xfrm>
-          <a:off x="0" y="0"/>
-          <a:ext cx="0" cy="0"/>
-          <a:chOff x="0" y="0"/>
-          <a:chExt cx="0" cy="0"/>
-        </a:xfrm>
-      </p:grpSpPr>
-      <p:sp>
-        <p:nvSpPr>
-          <p:cNvPr id="2" name="Text 0"/>
-          <p:cNvSpPr txBox="1"/>
-          <p:nvPr/>
-        </p:nvSpPr>
-        <p:spPr>
-          <a:xfrm>
-            <a:off x="731520" y="822960"/>
-            <a:ext cx="10515600" cy="822960"/>
-          </a:xfrm>
-          <a:prstGeom prst="rect">
-            <a:avLst/>
-          </a:prstGeom>
-          <a:noFill/>
-          <a:ln/>
-        </p:spPr>
-        <p:txBody>
-          <a:bodyPr wrap="square" lIns="0" tIns="0" rIns="0" bIns="0" rtlCol="0" anchor="ctr"/>
-          <a:lstStyle/>
-          <a:p>
-            <a:pPr indent="0" marL="0">
-              <a:buNone/>
-            </a:pPr>
-            <a:r>
-              <a:rPr lang="en-US" sz="3800" b="1" dirty="0">
-                <a:solidFill>
-                  <a:srgbClr val="FFFFFF"/>
-                </a:solidFill>
-                <a:latin typeface="Cambria" pitchFamily="34" charset="0"/>
-                <a:ea typeface="Cambria" pitchFamily="34" charset="-122"/>
-                <a:cs typeface="Cambria" pitchFamily="34" charset="-120"/>
-              </a:rPr>
-              <a:t>The ask: an experiment, not a policy</a:t>
-            </a:r>
-            <a:endParaRPr lang="en-US" sz="3800" dirty="0"/>
-          </a:p>
-        </p:txBody>
-      </p:sp>
-      <p:sp>
-        <p:nvSpPr>
-          <p:cNvPr id="3" name="Shape 1"/>
-          <p:cNvSpPr/>
-          <p:nvPr/>
-        </p:nvSpPr>
-        <p:spPr>
-          <a:xfrm>
-            <a:off x="731520" y="1874520"/>
-            <a:ext cx="502920" cy="502920"/>
-          </a:xfrm>
-          <a:prstGeom prst="ellipse">
-            <a:avLst/>
-          </a:prstGeom>
-          <a:solidFill>
-            <a:srgbClr val="D9480F"/>
-          </a:solidFill>
-          <a:ln w="12700">
-            <a:solidFill>
-              <a:srgbClr val="D9480F"/>
-            </a:solidFill>
-            <a:prstDash val="solid"/>
-          </a:ln>
-        </p:spPr>
-      </p:sp>
-      <p:sp>
-        <p:nvSpPr>
-          <p:cNvPr id="4" name="Text 2"/>
-          <p:cNvSpPr txBox="1"/>
-          <p:nvPr/>
-        </p:nvSpPr>
-        <p:spPr>
-          <a:xfrm>
-            <a:off x="731520" y="1874520"/>
-            <a:ext cx="502920" cy="502920"/>
-          </a:xfrm>
-          <a:prstGeom prst="rect">
-            <a:avLst/>
-          </a:prstGeom>
-          <a:noFill/>
-          <a:ln/>
-        </p:spPr>
-        <p:txBody>
-          <a:bodyPr wrap="square" lIns="0" tIns="0" rIns="0" bIns="0" rtlCol="0" anchor="ctr"/>
-          <a:lstStyle/>
-          <a:p>
-            <a:pPr algn="ctr" indent="0" marL="0">
-              <a:buNone/>
-            </a:pPr>
-            <a:r>
-              <a:rPr lang="en-US" sz="1600" b="1" dirty="0">
-                <a:solidFill>
-                  <a:srgbClr val="FFFFFF"/>
-                </a:solidFill>
-                <a:latin typeface="Calibri" pitchFamily="34" charset="0"/>
-                <a:ea typeface="Calibri" pitchFamily="34" charset="-122"/>
-                <a:cs typeface="Calibri" pitchFamily="34" charset="-120"/>
-              </a:rPr>
-              <a:t>1</a:t>
-            </a:r>
-            <a:endParaRPr lang="en-US" sz="1600" dirty="0"/>
-          </a:p>
-        </p:txBody>
-      </p:sp>
-      <p:sp>
-        <p:nvSpPr>
-          <p:cNvPr id="5" name="Text 3"/>
-          <p:cNvSpPr txBox="1"/>
-          <p:nvPr/>
-        </p:nvSpPr>
-        <p:spPr>
-          <a:xfrm>
-            <a:off x="1463040" y="1828800"/>
-            <a:ext cx="2743200" cy="548640"/>
-          </a:xfrm>
-          <a:prstGeom prst="rect">
-            <a:avLst/>
-          </a:prstGeom>
-          <a:noFill/>
-          <a:ln/>
-        </p:spPr>
-        <p:txBody>
-          <a:bodyPr wrap="square" lIns="0" tIns="0" rIns="0" bIns="0" rtlCol="0" anchor="ctr"/>
-          <a:lstStyle/>
-          <a:p>
-            <a:pPr indent="0" marL="0">
-              <a:buNone/>
-            </a:pPr>
-            <a:r>
-              <a:rPr lang="en-US" sz="2000" b="1" dirty="0">
-                <a:solidFill>
-                  <a:srgbClr val="FFFFFF"/>
-                </a:solidFill>
-                <a:latin typeface="Calibri" pitchFamily="34" charset="0"/>
-                <a:ea typeface="Calibri" pitchFamily="34" charset="-122"/>
-                <a:cs typeface="Calibri" pitchFamily="34" charset="-120"/>
-              </a:rPr>
-              <a:t>Next 50 PRs</a:t>
-            </a:r>
-            <a:endParaRPr lang="en-US" sz="2000" dirty="0"/>
-          </a:p>
-        </p:txBody>
-      </p:sp>
-      <p:sp>
-        <p:nvSpPr>
-          <p:cNvPr id="6" name="Text 4"/>
-          <p:cNvSpPr txBox="1"/>
-          <p:nvPr/>
-        </p:nvSpPr>
-        <p:spPr>
-          <a:xfrm>
-            <a:off x="4206240" y="1828800"/>
-            <a:ext cx="7315200" cy="914400"/>
-          </a:xfrm>
-          <a:prstGeom prst="rect">
-            <a:avLst/>
-          </a:prstGeom>
-          <a:noFill/>
-          <a:ln/>
-        </p:spPr>
-        <p:txBody>
-          <a:bodyPr wrap="square" lIns="0" tIns="0" rIns="0" bIns="0" rtlCol="0" anchor="ctr"/>
-          <a:lstStyle/>
-          <a:p>
-            <a:pPr indent="0" marL="0">
-              <a:buNone/>
-            </a:pPr>
-            <a:r>
-              <a:rPr lang="en-US" sz="1500" dirty="0">
-                <a:solidFill>
-                  <a:srgbClr val="D1D5DB"/>
-                </a:solidFill>
-                <a:latin typeface="Calibri" pitchFamily="34" charset="0"/>
-                <a:ea typeface="Calibri" pitchFamily="34" charset="-122"/>
-                <a:cs typeface="Calibri" pitchFamily="34" charset="-120"/>
-              </a:rPr>
-              <a:t>Developers run /done; the twin block lands in every PR description.</a:t>
-            </a:r>
-            <a:endParaRPr lang="en-US" sz="1500" dirty="0"/>
-          </a:p>
-        </p:txBody>
-      </p:sp>
-      <p:sp>
-        <p:nvSpPr>
-          <p:cNvPr id="7" name="Shape 5"/>
-          <p:cNvSpPr/>
-          <p:nvPr/>
-        </p:nvSpPr>
-        <p:spPr>
-          <a:xfrm>
-            <a:off x="731520" y="2926080"/>
-            <a:ext cx="502920" cy="502920"/>
-          </a:xfrm>
-          <a:prstGeom prst="ellipse">
-            <a:avLst/>
-          </a:prstGeom>
-          <a:solidFill>
-            <a:srgbClr val="D9480F"/>
-          </a:solidFill>
-          <a:ln w="12700">
-            <a:solidFill>
-              <a:srgbClr val="D9480F"/>
-            </a:solidFill>
-            <a:prstDash val="solid"/>
-          </a:ln>
-        </p:spPr>
-      </p:sp>
-      <p:sp>
-        <p:nvSpPr>
-          <p:cNvPr id="8" name="Text 6"/>
-          <p:cNvSpPr txBox="1"/>
-          <p:nvPr/>
-        </p:nvSpPr>
-        <p:spPr>
-          <a:xfrm>
-            <a:off x="731520" y="2926080"/>
-            <a:ext cx="502920" cy="502920"/>
-          </a:xfrm>
-          <a:prstGeom prst="rect">
-            <a:avLst/>
-          </a:prstGeom>
-          <a:noFill/>
-          <a:ln/>
-        </p:spPr>
-        <p:txBody>
-          <a:bodyPr wrap="square" lIns="0" tIns="0" rIns="0" bIns="0" rtlCol="0" anchor="ctr"/>
-          <a:lstStyle/>
-          <a:p>
-            <a:pPr algn="ctr" indent="0" marL="0">
-              <a:buNone/>
-            </a:pPr>
-            <a:r>
-              <a:rPr lang="en-US" sz="1600" b="1" dirty="0">
-                <a:solidFill>
-                  <a:srgbClr val="FFFFFF"/>
-                </a:solidFill>
-                <a:latin typeface="Calibri" pitchFamily="34" charset="0"/>
-                <a:ea typeface="Calibri" pitchFamily="34" charset="-122"/>
-                <a:cs typeface="Calibri" pitchFamily="34" charset="-120"/>
-              </a:rPr>
-              <a:t>2</a:t>
-            </a:r>
-            <a:endParaRPr lang="en-US" sz="1600" dirty="0"/>
-          </a:p>
-        </p:txBody>
-      </p:sp>
-      <p:sp>
-        <p:nvSpPr>
-          <p:cNvPr id="9" name="Text 7"/>
-          <p:cNvSpPr txBox="1"/>
-          <p:nvPr/>
-        </p:nvSpPr>
-        <p:spPr>
-          <a:xfrm>
-            <a:off x="1463040" y="2880360"/>
-            <a:ext cx="2743200" cy="548640"/>
-          </a:xfrm>
-          <a:prstGeom prst="rect">
-            <a:avLst/>
-          </a:prstGeom>
-          <a:noFill/>
-          <a:ln/>
-        </p:spPr>
-        <p:txBody>
-          <a:bodyPr wrap="square" lIns="0" tIns="0" rIns="0" bIns="0" rtlCol="0" anchor="ctr"/>
-          <a:lstStyle/>
-          <a:p>
-            <a:pPr indent="0" marL="0">
-              <a:buNone/>
-            </a:pPr>
-            <a:r>
-              <a:rPr lang="en-US" sz="2000" b="1" dirty="0">
-                <a:solidFill>
-                  <a:srgbClr val="FFFFFF"/>
-                </a:solidFill>
-                <a:latin typeface="Calibri" pitchFamily="34" charset="0"/>
-                <a:ea typeface="Calibri" pitchFamily="34" charset="-122"/>
-                <a:cs typeface="Calibri" pitchFamily="34" charset="-120"/>
-              </a:rPr>
-              <a:t>Calibrate first</a:t>
-            </a:r>
-            <a:endParaRPr lang="en-US" sz="2000" dirty="0"/>
-          </a:p>
-        </p:txBody>
-      </p:sp>
-      <p:sp>
-        <p:nvSpPr>
-          <p:cNvPr id="10" name="Text 8"/>
-          <p:cNvSpPr txBox="1"/>
-          <p:nvPr/>
-        </p:nvSpPr>
-        <p:spPr>
-          <a:xfrm>
-            <a:off x="4206240" y="2880360"/>
-            <a:ext cx="7315200" cy="914400"/>
-          </a:xfrm>
-          <a:prstGeom prst="rect">
-            <a:avLst/>
-          </a:prstGeom>
-          <a:noFill/>
-          <a:ln/>
-        </p:spPr>
-        <p:txBody>
-          <a:bodyPr wrap="square" lIns="0" tIns="0" rIns="0" bIns="0" rtlCol="0" anchor="ctr"/>
-          <a:lstStyle/>
-          <a:p>
-            <a:pPr indent="0" marL="0">
-              <a:buNone/>
-            </a:pPr>
-            <a:r>
-              <a:rPr lang="en-US" sz="1500" dirty="0">
-                <a:solidFill>
-                  <a:srgbClr val="D1D5DB"/>
-                </a:solidFill>
-                <a:latin typeface="Calibri" pitchFamily="34" charset="0"/>
-                <a:ea typeface="Calibri" pitchFamily="34" charset="-122"/>
-                <a:cs typeface="Calibri" pitchFamily="34" charset="-120"/>
-              </a:rPr>
-              <a:t>Run the twin on 20–30 already-merged PRs and compare with what human reviewers actually said. Answers “have you actually seen these?” with numbers.</a:t>
-            </a:r>
-            <a:endParaRPr lang="en-US" sz="1500" dirty="0"/>
-          </a:p>
-        </p:txBody>
-      </p:sp>
-      <p:sp>
-        <p:nvSpPr>
-          <p:cNvPr id="11" name="Shape 9"/>
-          <p:cNvSpPr/>
-          <p:nvPr/>
-        </p:nvSpPr>
-        <p:spPr>
-          <a:xfrm>
-            <a:off x="731520" y="3977640"/>
-            <a:ext cx="502920" cy="502920"/>
-          </a:xfrm>
-          <a:prstGeom prst="ellipse">
-            <a:avLst/>
-          </a:prstGeom>
-          <a:solidFill>
-            <a:srgbClr val="D9480F"/>
-          </a:solidFill>
-          <a:ln w="12700">
-            <a:solidFill>
-              <a:srgbClr val="D9480F"/>
-            </a:solidFill>
-            <a:prstDash val="solid"/>
-          </a:ln>
-        </p:spPr>
-      </p:sp>
-      <p:sp>
-        <p:nvSpPr>
-          <p:cNvPr id="12" name="Text 10"/>
-          <p:cNvSpPr txBox="1"/>
-          <p:nvPr/>
-        </p:nvSpPr>
-        <p:spPr>
-          <a:xfrm>
-            <a:off x="731520" y="3977640"/>
-            <a:ext cx="502920" cy="502920"/>
-          </a:xfrm>
-          <a:prstGeom prst="rect">
-            <a:avLst/>
-          </a:prstGeom>
-          <a:noFill/>
-          <a:ln/>
-        </p:spPr>
-        <p:txBody>
-          <a:bodyPr wrap="square" lIns="0" tIns="0" rIns="0" bIns="0" rtlCol="0" anchor="ctr"/>
-          <a:lstStyle/>
-          <a:p>
-            <a:pPr algn="ctr" indent="0" marL="0">
-              <a:buNone/>
-            </a:pPr>
-            <a:r>
-              <a:rPr lang="en-US" sz="1600" b="1" dirty="0">
-                <a:solidFill>
-                  <a:srgbClr val="FFFFFF"/>
-                </a:solidFill>
-                <a:latin typeface="Calibri" pitchFamily="34" charset="0"/>
-                <a:ea typeface="Calibri" pitchFamily="34" charset="-122"/>
-                <a:cs typeface="Calibri" pitchFamily="34" charset="-120"/>
-              </a:rPr>
-              <a:t>3</a:t>
-            </a:r>
-            <a:endParaRPr lang="en-US" sz="1600" dirty="0"/>
-          </a:p>
-        </p:txBody>
-      </p:sp>
-      <p:sp>
-        <p:nvSpPr>
-          <p:cNvPr id="13" name="Text 11"/>
-          <p:cNvSpPr txBox="1"/>
-          <p:nvPr/>
-        </p:nvSpPr>
-        <p:spPr>
-          <a:xfrm>
-            <a:off x="1463040" y="3931920"/>
-            <a:ext cx="2743200" cy="548640"/>
-          </a:xfrm>
-          <a:prstGeom prst="rect">
-            <a:avLst/>
-          </a:prstGeom>
-          <a:noFill/>
-          <a:ln/>
-        </p:spPr>
-        <p:txBody>
-          <a:bodyPr wrap="square" lIns="0" tIns="0" rIns="0" bIns="0" rtlCol="0" anchor="ctr"/>
-          <a:lstStyle/>
-          <a:p>
-            <a:pPr indent="0" marL="0">
-              <a:buNone/>
-            </a:pPr>
-            <a:r>
-              <a:rPr lang="en-US" sz="2000" b="1" dirty="0">
-                <a:solidFill>
-                  <a:srgbClr val="FFFFFF"/>
-                </a:solidFill>
-                <a:latin typeface="Calibri" pitchFamily="34" charset="0"/>
-                <a:ea typeface="Calibri" pitchFamily="34" charset="-122"/>
-                <a:cs typeface="Calibri" pitchFamily="34" charset="-120"/>
-              </a:rPr>
-              <a:t>Measure</a:t>
-            </a:r>
-            <a:endParaRPr lang="en-US" sz="2000" dirty="0"/>
-          </a:p>
-        </p:txBody>
-      </p:sp>
-      <p:sp>
-        <p:nvSpPr>
-          <p:cNvPr id="14" name="Text 12"/>
-          <p:cNvSpPr txBox="1"/>
-          <p:nvPr/>
-        </p:nvSpPr>
-        <p:spPr>
-          <a:xfrm>
-            <a:off x="4206240" y="3931920"/>
-            <a:ext cx="7315200" cy="914400"/>
-          </a:xfrm>
-          <a:prstGeom prst="rect">
-            <a:avLst/>
-          </a:prstGeom>
-          <a:noFill/>
-          <a:ln/>
-        </p:spPr>
-        <p:txBody>
-          <a:bodyPr wrap="square" lIns="0" tIns="0" rIns="0" bIns="0" rtlCol="0" anchor="ctr"/>
-          <a:lstStyle/>
-          <a:p>
-            <a:pPr indent="0" marL="0">
-              <a:buNone/>
-            </a:pPr>
-            <a:r>
-              <a:rPr lang="en-US" sz="1500" dirty="0">
-                <a:solidFill>
-                  <a:srgbClr val="D1D5DB"/>
-                </a:solidFill>
-                <a:latin typeface="Calibri" pitchFamily="34" charset="0"/>
-                <a:ea typeface="Calibri" pitchFamily="34" charset="-122"/>
-                <a:cs typeface="Calibri" pitchFamily="34" charset="-120"/>
-              </a:rPr>
-              <a:t>Median verbosity ratio of merged PRs, tracked for one quarter.</a:t>
-            </a:r>
-            <a:endParaRPr lang="en-US" sz="1500" dirty="0"/>
-          </a:p>
-        </p:txBody>
-      </p:sp>
-      <p:sp>
-        <p:nvSpPr>
-          <p:cNvPr id="15" name="Shape 13"/>
-          <p:cNvSpPr/>
-          <p:nvPr/>
-        </p:nvSpPr>
-        <p:spPr>
-          <a:xfrm>
-            <a:off x="731520" y="5029200"/>
-            <a:ext cx="502920" cy="502920"/>
-          </a:xfrm>
-          <a:prstGeom prst="ellipse">
-            <a:avLst/>
-          </a:prstGeom>
-          <a:solidFill>
-            <a:srgbClr val="D9480F"/>
-          </a:solidFill>
-          <a:ln w="12700">
-            <a:solidFill>
-              <a:srgbClr val="D9480F"/>
-            </a:solidFill>
-            <a:prstDash val="solid"/>
-          </a:ln>
-        </p:spPr>
-      </p:sp>
-      <p:sp>
-        <p:nvSpPr>
-          <p:cNvPr id="16" name="Text 14"/>
-          <p:cNvSpPr txBox="1"/>
-          <p:nvPr/>
-        </p:nvSpPr>
-        <p:spPr>
-          <a:xfrm>
-            <a:off x="731520" y="5029200"/>
-            <a:ext cx="502920" cy="502920"/>
-          </a:xfrm>
-          <a:prstGeom prst="rect">
-            <a:avLst/>
-          </a:prstGeom>
-          <a:noFill/>
-          <a:ln/>
-        </p:spPr>
-        <p:txBody>
-          <a:bodyPr wrap="square" lIns="0" tIns="0" rIns="0" bIns="0" rtlCol="0" anchor="ctr"/>
-          <a:lstStyle/>
-          <a:p>
-            <a:pPr algn="ctr" indent="0" marL="0">
-              <a:buNone/>
-            </a:pPr>
-            <a:r>
-              <a:rPr lang="en-US" sz="1600" b="1" dirty="0">
-                <a:solidFill>
-                  <a:srgbClr val="FFFFFF"/>
-                </a:solidFill>
-                <a:latin typeface="Calibri" pitchFamily="34" charset="0"/>
-                <a:ea typeface="Calibri" pitchFamily="34" charset="-122"/>
-                <a:cs typeface="Calibri" pitchFamily="34" charset="-120"/>
-              </a:rPr>
-              <a:t>4</a:t>
-            </a:r>
-            <a:endParaRPr lang="en-US" sz="1600" dirty="0"/>
-          </a:p>
-        </p:txBody>
-      </p:sp>
-      <p:sp>
-        <p:nvSpPr>
-          <p:cNvPr id="17" name="Text 15"/>
-          <p:cNvSpPr txBox="1"/>
-          <p:nvPr/>
-        </p:nvSpPr>
-        <p:spPr>
-          <a:xfrm>
-            <a:off x="1463040" y="4983480"/>
-            <a:ext cx="2743200" cy="548640"/>
-          </a:xfrm>
-          <a:prstGeom prst="rect">
-            <a:avLst/>
-          </a:prstGeom>
-          <a:noFill/>
-          <a:ln/>
-        </p:spPr>
-        <p:txBody>
-          <a:bodyPr wrap="square" lIns="0" tIns="0" rIns="0" bIns="0" rtlCol="0" anchor="ctr"/>
-          <a:lstStyle/>
-          <a:p>
-            <a:pPr indent="0" marL="0">
-              <a:buNone/>
-            </a:pPr>
-            <a:r>
-              <a:rPr lang="en-US" sz="2000" b="1" dirty="0">
-                <a:solidFill>
-                  <a:srgbClr val="FFFFFF"/>
-                </a:solidFill>
-                <a:latin typeface="Calibri" pitchFamily="34" charset="0"/>
-                <a:ea typeface="Calibri" pitchFamily="34" charset="-122"/>
-                <a:cs typeface="Calibri" pitchFamily="34" charset="-120"/>
-              </a:rPr>
-              <a:t>Decide</a:t>
-            </a:r>
-            <a:endParaRPr lang="en-US" sz="2000" dirty="0"/>
-          </a:p>
-        </p:txBody>
-      </p:sp>
-      <p:sp>
-        <p:nvSpPr>
-          <p:cNvPr id="18" name="Text 16"/>
-          <p:cNvSpPr txBox="1"/>
-          <p:nvPr/>
-        </p:nvSpPr>
-        <p:spPr>
-          <a:xfrm>
-            <a:off x="4206240" y="4983480"/>
-            <a:ext cx="7315200" cy="914400"/>
-          </a:xfrm>
-          <a:prstGeom prst="rect">
-            <a:avLst/>
-          </a:prstGeom>
-          <a:noFill/>
-          <a:ln/>
-        </p:spPr>
-        <p:txBody>
-          <a:bodyPr wrap="square" lIns="0" tIns="0" rIns="0" bIns="0" rtlCol="0" anchor="ctr"/>
-          <a:lstStyle/>
-          <a:p>
-            <a:pPr indent="0" marL="0">
-              <a:buNone/>
-            </a:pPr>
-            <a:r>
-              <a:rPr lang="en-US" sz="1500" dirty="0">
-                <a:solidFill>
-                  <a:srgbClr val="D1D5DB"/>
-                </a:solidFill>
-                <a:latin typeface="Calibri" pitchFamily="34" charset="0"/>
-                <a:ea typeface="Calibri" pitchFamily="34" charset="-122"/>
-                <a:cs typeface="Calibri" pitchFamily="34" charset="-120"/>
-              </a:rPr>
-              <a:t>If the median drops: wire the PR-agent paragraph in and call it a standard. If it doesn't: delete the pack.</a:t>
-            </a:r>
-            <a:endParaRPr lang="en-US" sz="1500" dirty="0"/>
-          </a:p>
-        </p:txBody>
-      </p:sp>
-      <p:sp>
-        <p:nvSpPr>
-          <p:cNvPr id="19" name="Text 17"/>
-          <p:cNvSpPr txBox="1"/>
-          <p:nvPr/>
-        </p:nvSpPr>
-        <p:spPr>
-          <a:xfrm>
-            <a:off x="548640" y="6400800"/>
-            <a:ext cx="5486400" cy="274320"/>
-          </a:xfrm>
-          <a:prstGeom prst="rect">
-            <a:avLst/>
-          </a:prstGeom>
-          <a:noFill/>
-          <a:ln/>
-        </p:spPr>
-        <p:txBody>
-          <a:bodyPr wrap="square" lIns="0" tIns="0" rIns="0" bIns="0" rtlCol="0" anchor="ctr"/>
-          <a:lstStyle/>
-          <a:p>
-            <a:pPr indent="0" marL="0">
-              <a:buNone/>
-            </a:pPr>
-            <a:r>
-              <a:rPr lang="en-US" sz="1000" dirty="0">
-                <a:solidFill>
-                  <a:srgbClr val="9CA3AF"/>
-                </a:solidFill>
-                <a:latin typeface="Calibri" pitchFamily="34" charset="0"/>
-                <a:ea typeface="Calibri" pitchFamily="34" charset="-122"/>
-                <a:cs typeface="Calibri" pitchFamily="34" charset="-120"/>
-              </a:rPr>
-              <a:t>Minimal Twin · team review</a:t>
-            </a:r>
-            <a:endParaRPr lang="en-US" sz="1000" dirty="0"/>
           </a:p>
         </p:txBody>
       </p:sp>
@@ -3932,7 +3165,7 @@
                 <a:ea typeface="Calibri" pitchFamily="34" charset="-122"/>
                 <a:cs typeface="Calibri" pitchFamily="34" charset="-120"/>
               </a:rPr>
-              <a:t>1  Task + base code</a:t>
+              <a:t>1  The brief</a:t>
             </a:r>
             <a:endParaRPr lang="en-US" sz="1700" dirty="0"/>
           </a:p>
@@ -3971,30 +3204,7 @@
                 <a:ea typeface="Calibri" pitchFamily="34" charset="-122"/>
                 <a:cs typeface="Calibri" pitchFamily="34" charset="-120"/>
               </a:rPr>
-              <a:t>Recovered from the diff and commit message. The base as it was before the change.</a:t>
-            </a:r>
-            <a:endParaRPr lang="en-US" sz="1300" dirty="0"/>
-          </a:p>
-          <a:p>
-            <a:pPr indent="0" marL="0">
-              <a:buNone/>
-            </a:pPr>
-            <a:endParaRPr lang="en-US" sz="1300" dirty="0"/>
-          </a:p>
-          <a:p>
-            <a:pPr indent="0" marL="0">
-              <a:buNone/>
-            </a:pPr>
-            <a:r>
-              <a:rPr lang="en-US" sz="1300" dirty="0">
-                <a:solidFill>
-                  <a:srgbClr val="24292F"/>
-                </a:solidFill>
-                <a:latin typeface="Calibri" pitchFamily="34" charset="0"/>
-                <a:ea typeface="Calibri" pitchFamily="34" charset="-122"/>
-                <a:cs typeface="Calibri" pitchFamily="34" charset="-120"/>
-              </a:rPr>
-              <a:t>The twin author never sees the diff.</a:t>
+              <a:t>Given / When / Then acceptance criteria — behaviour only, never structure. From feature files if you have them; otherwise from the prompts the harness recorded on the branch, confirmed by the developer once.</a:t>
             </a:r>
             <a:endParaRPr lang="en-US" sz="1300" dirty="0"/>
           </a:p>
@@ -4060,7 +3270,7 @@
                 <a:ea typeface="Calibri" pitchFamily="34" charset="-122"/>
                 <a:cs typeface="Calibri" pitchFamily="34" charset="-120"/>
               </a:rPr>
-              <a:t>2  Twin (isolated)</a:t>
+              <a:t>2  Twin, built blind</a:t>
             </a:r>
             <a:endParaRPr lang="en-US" sz="1700" dirty="0"/>
           </a:p>
@@ -4099,7 +3309,7 @@
                 <a:ea typeface="Calibri" pitchFamily="34" charset="-122"/>
                 <a:cs typeface="Calibri" pitchFamily="34" charset="-120"/>
               </a:rPr>
-              <a:t>A subagent implements the task as small as correctly possible. Existing tests pass, minimum new tests.</a:t>
+              <a:t>The twin-builder subagent gets only the brief and a checkout of the base. Own context window; never sees the diff. Makes the criteria pass with the least correct code.</a:t>
             </a:r>
             <a:endParaRPr lang="en-US" sz="1300" dirty="0"/>
           </a:p>
@@ -4188,7 +3398,7 @@
                 <a:ea typeface="Calibri" pitchFamily="34" charset="-122"/>
                 <a:cs typeface="Calibri" pitchFamily="34" charset="-120"/>
               </a:rPr>
-              <a:t>3  Measure</a:t>
+              <a:t>3  Measure the whole change</a:t>
             </a:r>
             <a:endParaRPr lang="en-US" sz="1700" dirty="0"/>
           </a:p>
@@ -4227,7 +3437,7 @@
                 <a:ea typeface="Calibri" pitchFamily="34" charset="-122"/>
                 <a:cs typeface="Calibri" pitchFamily="34" charset="-120"/>
               </a:rPr>
-              <a:t>Verbosity ratio = lines added ÷ lines the twin needed.</a:t>
+              <a:t>Verbosity ratio = lines added ÷ lines the twin needed. Extra declarations = what the diff has that the twin does not.</a:t>
             </a:r>
             <a:endParaRPr lang="en-US" sz="1300" dirty="0"/>
           </a:p>
@@ -4250,7 +3460,7 @@
                 <a:ea typeface="Calibri" pitchFamily="34" charset="-122"/>
                 <a:cs typeface="Calibri" pitchFamily="34" charset="-120"/>
               </a:rPr>
-              <a:t>Extra declarations = what the diff added that the twin did not.</a:t>
+              <a:t>Whoever or whatever wrote it — hand edits count.</a:t>
             </a:r>
             <a:endParaRPr lang="en-US" sz="1300" dirty="0"/>
           </a:p>
@@ -4405,7 +3615,7 @@
                 <a:ea typeface="Calibri" pitchFamily="34" charset="-122"/>
                 <a:cs typeface="Calibri" pitchFamily="34" charset="-120"/>
               </a:rPr>
-              <a:t>For every extra declaration: what breaks if I delete it and inline the caller?   Nothing → delete.   Only its own test → delete both.   A behaviour the twin also has → twin is wrong, fix it.   A behaviour the twin lacks → task statement was incomplete, keep it.</a:t>
+              <a:t>For every extra declaration, one question answered by reading the code: what breaks if I delete it and inline the caller?   Nothing → delete.   Only its own test → delete both.   A behaviour the brief lacks → the brief was incomplete: add it, extend the twin, recount.</a:t>
             </a:r>
             <a:endParaRPr lang="en-US" sz="1300" dirty="0"/>
           </a:p>
@@ -4428,7 +3638,7 @@
                 <a:ea typeface="Calibri" pitchFamily="34" charset="-122"/>
                 <a:cs typeface="Calibri" pitchFamily="34" charset="-120"/>
               </a:rPr>
-              <a:t>Then two short passes the twin cannot answer: tests at the boundaries, and security gaps scanners cannot see.</a:t>
+              <a:t>The twin measures size, not safety: tests at the boundaries and security gaps get their own short look. Only a bug, a vulnerability, a broken contract or untested behaviour can fail the review.</a:t>
             </a:r>
             <a:endParaRPr lang="en-US" sz="1300" dirty="0"/>
           </a:p>
@@ -4641,7 +3851,7 @@
                 <a:ea typeface="Calibri" pitchFamily="34" charset="-122"/>
                 <a:cs typeface="Calibri" pitchFamily="34" charset="-120"/>
               </a:rPr>
-              <a:t>/quality-review  →  twin built, ratio, delete list (~4 min)</a:t>
+              <a:t>/quality-review  →  twin-builder subagent spawns, ratio, delete list (~4 min)</a:t>
             </a:r>
             <a:endParaRPr lang="en-US" sz="2000" dirty="0"/>
           </a:p>
@@ -5440,7 +4650,7 @@
                 <a:ea typeface="Cambria" pitchFamily="34" charset="-122"/>
                 <a:cs typeface="Cambria" pitchFamily="34" charset="-120"/>
               </a:rPr>
-              <a:t>The workflow: two commands, one optional line of config</a:t>
+              <a:t>The workflow: two commands, two optional hooks</a:t>
             </a:r>
             <a:endParaRPr lang="en-US" sz="3400" dirty="0"/>
           </a:p>
@@ -5584,7 +4794,7 @@
                 <a:ea typeface="Calibri" pitchFamily="34" charset="-122"/>
                 <a:cs typeface="Calibri" pitchFamily="34" charset="-120"/>
               </a:rPr>
-              <a:t>The minimal-twin review on the current diff. Verdict, ratio, delete list, tests and security passes. Offers to apply the deletions.</a:t>
+              <a:t>The minimal-twin review on the current diff. Brief → blind twin → ratio → delete list → tests and security. Offers to apply the deletions.</a:t>
             </a:r>
             <a:endParaRPr lang="en-US" sz="1400" dirty="0"/>
           </a:p>
@@ -5728,30 +4938,7 @@
                 <a:ea typeface="Calibri" pitchFamily="34" charset="-122"/>
                 <a:cs typeface="Calibri" pitchFamily="34" charset="-120"/>
               </a:rPr>
-              <a:t>gradle check green → twin review applied → every new behaviour tested at its boundaries → summary with the ratio before and after.</a:t>
-            </a:r>
-            <a:endParaRPr lang="en-US" sz="1400" dirty="0"/>
-          </a:p>
-          <a:p>
-            <a:pPr indent="0" marL="0">
-              <a:buNone/>
-            </a:pPr>
-            <a:endParaRPr lang="en-US" sz="1400" dirty="0"/>
-          </a:p>
-          <a:p>
-            <a:pPr indent="0" marL="0">
-              <a:buNone/>
-            </a:pPr>
-            <a:r>
-              <a:rPr lang="en-US" sz="1400" dirty="0">
-                <a:solidFill>
-                  <a:srgbClr val="E5E7EB"/>
-                </a:solidFill>
-                <a:latin typeface="Calibri" pitchFamily="34" charset="0"/>
-                <a:ea typeface="Calibri" pitchFamily="34" charset="-122"/>
-                <a:cs typeface="Calibri" pitchFamily="34" charset="-120"/>
-              </a:rPr>
-              <a:t>The loop developers run instead of a reviewer catching it later.</a:t>
+              <a:t>gradle check green → brief condensed from the prompt log, confirmed in one question → twin review applied → criteria recorded on the commit → summary with the ratio before and after.</a:t>
             </a:r>
             <a:endParaRPr lang="en-US" sz="1400" dirty="0"/>
           </a:p>
@@ -5817,7 +5004,7 @@
                 <a:ea typeface="Courier New" pitchFamily="34" charset="-122"/>
                 <a:cs typeface="Courier New" pitchFamily="34" charset="-120"/>
               </a:rPr>
-              <a:t>AfterAgent hook</a:t>
+              <a:t>Two hooks</a:t>
             </a:r>
             <a:endParaRPr lang="en-US" sz="2000" dirty="0"/>
           </a:p>
@@ -5856,7 +5043,7 @@
                 <a:ea typeface="Calibri" pitchFamily="34" charset="-122"/>
                 <a:cs typeface="Calibri" pitchFamily="34" charset="-120"/>
               </a:rPr>
-              <a:t>optional, once per task</a:t>
+              <a:t>optional, one line each</a:t>
             </a:r>
             <a:endParaRPr lang="en-US" sz="1200" dirty="0"/>
           </a:p>
@@ -5895,7 +5082,7 @@
                 <a:ea typeface="Calibri" pitchFamily="34" charset="-122"/>
                 <a:cs typeface="Calibri" pitchFamily="34" charset="-120"/>
               </a:rPr>
-              <a:t>./gradlew -q check</a:t>
+              <a:t>prompt-log: records every prompt the developer types, per branch, so the brief comes from what was actually asked.</a:t>
             </a:r>
             <a:endParaRPr lang="en-US" sz="1400" dirty="0"/>
           </a:p>
@@ -5918,7 +5105,7 @@
                 <a:ea typeface="Calibri" pitchFamily="34" charset="-122"/>
                 <a:cs typeface="Calibri" pitchFamily="34" charset="-120"/>
               </a:rPr>
-              <a:t>The repo's own Checkstyle, PMD, Spotless, tests. Non-zero denies “done”. Nothing of ours; never per iteration.</a:t>
+              <a:t>build-checks: the repo's own gradle check once per turn; failure denies “done”.</a:t>
             </a:r>
             <a:endParaRPr lang="en-US" sz="1400" dirty="0"/>
           </a:p>
@@ -6832,7 +6019,7 @@
     <p:bg>
       <p:bgPr>
         <a:solidFill>
-          <a:srgbClr val="FFFFFF"/>
+          <a:srgbClr val="1B1F24"/>
         </a:solidFill>
       </p:bgPr>
     </p:bg>
@@ -6858,8 +6045,8 @@
         </p:nvSpPr>
         <p:spPr>
           <a:xfrm>
-            <a:off x="548640" y="411480"/>
-            <a:ext cx="11064240" cy="822960"/>
+            <a:off x="731520" y="640080"/>
+            <a:ext cx="10515600" cy="822960"/>
           </a:xfrm>
           <a:prstGeom prst="rect">
             <a:avLst/>
@@ -6875,17 +6062,17 @@
               <a:buNone/>
             </a:pPr>
             <a:r>
-              <a:rPr lang="en-US" sz="3400" b="1" dirty="0">
-                <a:solidFill>
-                  <a:srgbClr val="24292F"/>
+              <a:rPr lang="en-US" sz="3800" b="1" dirty="0">
+                <a:solidFill>
+                  <a:srgbClr val="FFFFFF"/>
                 </a:solidFill>
                 <a:latin typeface="Cambria" pitchFamily="34" charset="0"/>
                 <a:ea typeface="Cambria" pitchFamily="34" charset="-122"/>
                 <a:cs typeface="Cambria" pitchFamily="34" charset="-120"/>
               </a:rPr>
-              <a:t>What it costs to keep</a:t>
-            </a:r>
-            <a:endParaRPr lang="en-US" sz="3400" dirty="0"/>
+              <a:t>The ask: an experiment, not a policy</a:t>
+            </a:r>
+            <a:endParaRPr lang="en-US" sz="3800" dirty="0"/>
           </a:p>
         </p:txBody>
       </p:sp>
@@ -6897,8 +6084,8 @@
         </p:nvSpPr>
         <p:spPr>
           <a:xfrm>
-            <a:off x="548640" y="1645920"/>
-            <a:ext cx="3566160" cy="1280160"/>
+            <a:off x="731520" y="1371600"/>
+            <a:ext cx="10515600" cy="365760"/>
           </a:xfrm>
           <a:prstGeom prst="rect">
             <a:avLst/>
@@ -6910,62 +6097,48 @@
           <a:bodyPr wrap="square" lIns="0" tIns="0" rIns="0" bIns="0" rtlCol="0" anchor="ctr"/>
           <a:lstStyle/>
           <a:p>
-            <a:pPr algn="ctr" indent="0" marL="0">
-              <a:buNone/>
-            </a:pPr>
-            <a:r>
-              <a:rPr lang="en-US" sz="6400" b="1" dirty="0">
-                <a:solidFill>
-                  <a:srgbClr val="24292F"/>
-                </a:solidFill>
-                <a:latin typeface="Cambria" pitchFamily="34" charset="0"/>
-                <a:ea typeface="Cambria" pitchFamily="34" charset="-122"/>
-                <a:cs typeface="Cambria" pitchFamily="34" charset="-120"/>
-              </a:rPr>
-              <a:t>258</a:t>
-            </a:r>
-            <a:endParaRPr lang="en-US" sz="6400" dirty="0"/>
-          </a:p>
-        </p:txBody>
-      </p:sp>
-      <p:sp>
-        <p:nvSpPr>
-          <p:cNvPr id="4" name="Text 2"/>
-          <p:cNvSpPr txBox="1"/>
-          <p:nvPr/>
-        </p:nvSpPr>
-        <p:spPr>
-          <a:xfrm>
-            <a:off x="548640" y="2926080"/>
-            <a:ext cx="3566160" cy="548640"/>
-          </a:xfrm>
-          <a:prstGeom prst="rect">
-            <a:avLst/>
-          </a:prstGeom>
-          <a:noFill/>
-          <a:ln/>
-        </p:spPr>
-        <p:txBody>
-          <a:bodyPr wrap="square" lIns="0" tIns="0" rIns="0" bIns="0" rtlCol="0" anchor="ctr"/>
-          <a:lstStyle/>
-          <a:p>
-            <a:pPr algn="ctr" indent="0" marL="0">
-              <a:buNone/>
-            </a:pPr>
-            <a:r>
-              <a:rPr lang="en-US" sz="1600" dirty="0">
-                <a:solidFill>
-                  <a:srgbClr val="6B7280"/>
+            <a:pPr indent="0" marL="0">
+              <a:buNone/>
+            </a:pPr>
+            <a:r>
+              <a:rPr lang="en-US" sz="1400" i="1" dirty="0">
+                <a:solidFill>
+                  <a:srgbClr val="D9480F"/>
                 </a:solidFill>
                 <a:latin typeface="Calibri" pitchFamily="34" charset="0"/>
                 <a:ea typeface="Calibri" pitchFamily="34" charset="-122"/>
                 <a:cs typeface="Calibri" pitchFamily="34" charset="-120"/>
               </a:rPr>
-              <a:t>lines of markdown + TOML</a:t>
-            </a:r>
-            <a:endParaRPr lang="en-US" sz="1600" dirty="0"/>
-          </a:p>
-        </p:txBody>
+              <a:t>Cost to keep: ~280 lines of markdown, 0 scripts, 0 CI changes. When the models move, we edit a paragraph, not a parser.</a:t>
+            </a:r>
+            <a:endParaRPr lang="en-US" sz="1400" dirty="0"/>
+          </a:p>
+        </p:txBody>
+      </p:sp>
+      <p:sp>
+        <p:nvSpPr>
+          <p:cNvPr id="4" name="Shape 2"/>
+          <p:cNvSpPr/>
+          <p:nvPr/>
+        </p:nvSpPr>
+        <p:spPr>
+          <a:xfrm>
+            <a:off x="731520" y="2057400"/>
+            <a:ext cx="502920" cy="502920"/>
+          </a:xfrm>
+          <a:prstGeom prst="ellipse">
+            <a:avLst/>
+          </a:prstGeom>
+          <a:solidFill>
+            <a:srgbClr val="D9480F"/>
+          </a:solidFill>
+          <a:ln w="12700">
+            <a:solidFill>
+              <a:srgbClr val="D9480F"/>
+            </a:solidFill>
+            <a:prstDash val="solid"/>
+          </a:ln>
+        </p:spPr>
       </p:sp>
       <p:sp>
         <p:nvSpPr>
@@ -6975,8 +6148,8 @@
         </p:nvSpPr>
         <p:spPr>
           <a:xfrm>
-            <a:off x="4297680" y="1645920"/>
-            <a:ext cx="3566160" cy="1280160"/>
+            <a:off x="731520" y="2057400"/>
+            <a:ext cx="502920" cy="502920"/>
           </a:xfrm>
           <a:prstGeom prst="rect">
             <a:avLst/>
@@ -6992,54 +6165,15 @@
               <a:buNone/>
             </a:pPr>
             <a:r>
-              <a:rPr lang="en-US" sz="6400" b="1" dirty="0">
-                <a:solidFill>
-                  <a:srgbClr val="24292F"/>
-                </a:solidFill>
-                <a:latin typeface="Cambria" pitchFamily="34" charset="0"/>
-                <a:ea typeface="Cambria" pitchFamily="34" charset="-122"/>
-                <a:cs typeface="Cambria" pitchFamily="34" charset="-120"/>
-              </a:rPr>
-              <a:t>0</a:t>
-            </a:r>
-            <a:endParaRPr lang="en-US" sz="6400" dirty="0"/>
-          </a:p>
-        </p:txBody>
-      </p:sp>
-      <p:sp>
-        <p:nvSpPr>
-          <p:cNvPr id="6" name="Text 4"/>
-          <p:cNvSpPr txBox="1"/>
-          <p:nvPr/>
-        </p:nvSpPr>
-        <p:spPr>
-          <a:xfrm>
-            <a:off x="4297680" y="2926080"/>
-            <a:ext cx="3566160" cy="548640"/>
-          </a:xfrm>
-          <a:prstGeom prst="rect">
-            <a:avLst/>
-          </a:prstGeom>
-          <a:noFill/>
-          <a:ln/>
-        </p:spPr>
-        <p:txBody>
-          <a:bodyPr wrap="square" lIns="0" tIns="0" rIns="0" bIns="0" rtlCol="0" anchor="ctr"/>
-          <a:lstStyle/>
-          <a:p>
-            <a:pPr algn="ctr" indent="0" marL="0">
-              <a:buNone/>
-            </a:pPr>
-            <a:r>
-              <a:rPr lang="en-US" sz="1600" dirty="0">
-                <a:solidFill>
-                  <a:srgbClr val="6B7280"/>
+              <a:rPr lang="en-US" sz="1600" b="1" dirty="0">
+                <a:solidFill>
+                  <a:srgbClr val="FFFFFF"/>
                 </a:solidFill>
                 <a:latin typeface="Calibri" pitchFamily="34" charset="0"/>
                 <a:ea typeface="Calibri" pitchFamily="34" charset="-122"/>
                 <a:cs typeface="Calibri" pitchFamily="34" charset="-120"/>
               </a:rPr>
-              <a:t>scripts to maintain</a:t>
+              <a:t>1</a:t>
             </a:r>
             <a:endParaRPr lang="en-US" sz="1600" dirty="0"/>
           </a:p>
@@ -7047,14 +6181,14 @@
       </p:sp>
       <p:sp>
         <p:nvSpPr>
-          <p:cNvPr id="7" name="Text 5"/>
+          <p:cNvPr id="6" name="Text 4"/>
           <p:cNvSpPr txBox="1"/>
           <p:nvPr/>
         </p:nvSpPr>
         <p:spPr>
           <a:xfrm>
-            <a:off x="8046720" y="1645920"/>
-            <a:ext cx="3566160" cy="1280160"/>
+            <a:off x="1463040" y="2011680"/>
+            <a:ext cx="2743200" cy="548640"/>
           </a:xfrm>
           <a:prstGeom prst="rect">
             <a:avLst/>
@@ -7066,504 +6200,34 @@
           <a:bodyPr wrap="square" lIns="0" tIns="0" rIns="0" bIns="0" rtlCol="0" anchor="ctr"/>
           <a:lstStyle/>
           <a:p>
-            <a:pPr algn="ctr" indent="0" marL="0">
-              <a:buNone/>
-            </a:pPr>
-            <a:r>
-              <a:rPr lang="en-US" sz="6400" b="1" dirty="0">
-                <a:solidFill>
-                  <a:srgbClr val="24292F"/>
-                </a:solidFill>
-                <a:latin typeface="Cambria" pitchFamily="34" charset="0"/>
-                <a:ea typeface="Cambria" pitchFamily="34" charset="-122"/>
-                <a:cs typeface="Cambria" pitchFamily="34" charset="-120"/>
-              </a:rPr>
-              <a:t>0</a:t>
-            </a:r>
-            <a:endParaRPr lang="en-US" sz="6400" dirty="0"/>
-          </a:p>
-        </p:txBody>
-      </p:sp>
-      <p:sp>
-        <p:nvSpPr>
-          <p:cNvPr id="8" name="Text 6"/>
-          <p:cNvSpPr txBox="1"/>
-          <p:nvPr/>
-        </p:nvSpPr>
-        <p:spPr>
-          <a:xfrm>
-            <a:off x="8046720" y="2926080"/>
-            <a:ext cx="3566160" cy="548640"/>
-          </a:xfrm>
-          <a:prstGeom prst="rect">
-            <a:avLst/>
-          </a:prstGeom>
-          <a:noFill/>
-          <a:ln/>
-        </p:spPr>
-        <p:txBody>
-          <a:bodyPr wrap="square" lIns="0" tIns="0" rIns="0" bIns="0" rtlCol="0" anchor="ctr"/>
-          <a:lstStyle/>
-          <a:p>
-            <a:pPr algn="ctr" indent="0" marL="0">
-              <a:buNone/>
-            </a:pPr>
-            <a:r>
-              <a:rPr lang="en-US" sz="1600" dirty="0">
-                <a:solidFill>
-                  <a:srgbClr val="6B7280"/>
+            <a:pPr indent="0" marL="0">
+              <a:buNone/>
+            </a:pPr>
+            <a:r>
+              <a:rPr lang="en-US" sz="2000" b="1" dirty="0">
+                <a:solidFill>
+                  <a:srgbClr val="FFFFFF"/>
                 </a:solidFill>
                 <a:latin typeface="Calibri" pitchFamily="34" charset="0"/>
                 <a:ea typeface="Calibri" pitchFamily="34" charset="-122"/>
                 <a:cs typeface="Calibri" pitchFamily="34" charset="-120"/>
               </a:rPr>
-              <a:t>CI changes required</a:t>
-            </a:r>
-            <a:endParaRPr lang="en-US" sz="1600" dirty="0"/>
-          </a:p>
-        </p:txBody>
-      </p:sp>
-      <p:graphicFrame>
-        <p:nvGraphicFramePr>
-          <p:cNvPr id="10" name="Table 0"/>
-          <p:cNvGraphicFramePr>
-            <a:graphicFrameLocks noGrp="1"/>
-          </p:cNvGraphicFramePr>
-          <p:nvPr>
-            <p:extLst>
-              <p:ext uri="{D42A27DB-BD31-4B8C-83A1-F6EECF244321}">
-                <p14:modId xmlns:p14="http://schemas.microsoft.com/office/powerpoint/2010/main" val="1579011935"/>
-              </p:ext>
-            </p:extLst>
-          </p:nvPr>
-        </p:nvGraphicFramePr>
-        <p:xfrm>
-          <a:off x="548640" y="3931920"/>
-          <a:ext cx="11064240" cy="914400"/>
-        </p:xfrm>
-        <a:graphic>
-          <a:graphicData uri="http://schemas.openxmlformats.org/drawingml/2006/table">
-            <a:tbl>
-              <a:tblPr/>
-              <a:tblGrid>
-                <a:gridCol w="1097280"/>
-                <a:gridCol w="5852160"/>
-                <a:gridCol w="4114800"/>
-              </a:tblGrid>
-              <a:tr h="731520">
-                <a:tc>
-                  <a:txBody>
-                    <a:bodyPr/>
-                    <a:lstStyle/>
-                    <a:p>
-                      <a:pPr algn="ctr" indent="0" marL="0">
-                        <a:buNone/>
-                      </a:pPr>
-                      <a:r>
-                        <a:rPr lang="en-US" sz="1500" b="1" dirty="0">
-                          <a:solidFill>
-                            <a:srgbClr val="24292F"/>
-                          </a:solidFill>
-                          <a:latin typeface="Calibri" pitchFamily="34" charset="0"/>
-                          <a:ea typeface="Calibri" pitchFamily="34" charset="-122"/>
-                          <a:cs typeface="Calibri" pitchFamily="34" charset="-120"/>
-                        </a:rPr>
-                        <a:t>v1</a:t>
-                      </a:r>
-                      <a:endParaRPr lang="en-US" sz="1500" dirty="0">
-                        <a:latin typeface="Calibri" charset="0"/>
-                        <a:ea typeface="Calibri" charset="0"/>
-                        <a:cs typeface="Calibri" charset="0"/>
-                      </a:endParaRPr>
-                    </a:p>
-                  </a:txBody>
-                  <a:tcPr marL="91440" marR="91440" marT="45720" marB="45720" anchor="ctr">
-                    <a:lnL w="38100" cap="flat" cmpd="sng" algn="ctr">
-                      <a:solidFill>
-                        <a:srgbClr val="FFFFFF"/>
-                      </a:solidFill>
-                      <a:prstDash val="solid"/>
-                      <a:round/>
-                      <a:headEnd type="none" w="med" len="med"/>
-                      <a:tailEnd type="none" w="med" len="med"/>
-                    </a:lnL>
-                    <a:lnR w="38100" cap="flat" cmpd="sng" algn="ctr">
-                      <a:solidFill>
-                        <a:srgbClr val="FFFFFF"/>
-                      </a:solidFill>
-                      <a:prstDash val="solid"/>
-                      <a:round/>
-                      <a:headEnd type="none" w="med" len="med"/>
-                      <a:tailEnd type="none" w="med" len="med"/>
-                    </a:lnR>
-                    <a:lnT w="38100" cap="flat" cmpd="sng" algn="ctr">
-                      <a:solidFill>
-                        <a:srgbClr val="FFFFFF"/>
-                      </a:solidFill>
-                      <a:prstDash val="solid"/>
-                      <a:round/>
-                      <a:headEnd type="none" w="med" len="med"/>
-                      <a:tailEnd type="none" w="med" len="med"/>
-                    </a:lnT>
-                    <a:lnB w="38100" cap="flat" cmpd="sng" algn="ctr">
-                      <a:solidFill>
-                        <a:srgbClr val="FFFFFF"/>
-                      </a:solidFill>
-                      <a:prstDash val="solid"/>
-                      <a:round/>
-                      <a:headEnd type="none" w="med" len="med"/>
-                      <a:tailEnd type="none" w="med" len="med"/>
-                    </a:lnB>
-                    <a:solidFill>
-                      <a:srgbClr val="F3F4F6"/>
-                    </a:solidFill>
-                  </a:tcPr>
-                </a:tc>
-                <a:tc>
-                  <a:txBody>
-                    <a:bodyPr/>
-                    <a:lstStyle/>
-                    <a:p>
-                      <a:pPr indent="0" marL="0">
-                        <a:buNone/>
-                      </a:pPr>
-                      <a:r>
-                        <a:rPr lang="en-US" sz="1400" dirty="0">
-                          <a:solidFill>
-                            <a:srgbClr val="24292F"/>
-                          </a:solidFill>
-                          <a:latin typeface="Calibri" pitchFamily="34" charset="0"/>
-                          <a:ea typeface="Calibri" pitchFamily="34" charset="-122"/>
-                          <a:cs typeface="Calibri" pitchFamily="34" charset="-120"/>
-                        </a:rPr>
-                        <a:t>qcheck.sh + two rulesets + pinned scanners + per-iteration hook + 5 skills</a:t>
-                      </a:r>
-                      <a:endParaRPr lang="en-US" sz="1400" dirty="0">
-                        <a:latin typeface="Calibri" charset="0"/>
-                        <a:ea typeface="Calibri" charset="0"/>
-                        <a:cs typeface="Calibri" charset="0"/>
-                      </a:endParaRPr>
-                    </a:p>
-                  </a:txBody>
-                  <a:tcPr marL="91440" marR="91440" marT="45720" marB="45720" anchor="ctr">
-                    <a:lnL w="38100" cap="flat" cmpd="sng" algn="ctr">
-                      <a:solidFill>
-                        <a:srgbClr val="FFFFFF"/>
-                      </a:solidFill>
-                      <a:prstDash val="solid"/>
-                      <a:round/>
-                      <a:headEnd type="none" w="med" len="med"/>
-                      <a:tailEnd type="none" w="med" len="med"/>
-                    </a:lnL>
-                    <a:lnR w="38100" cap="flat" cmpd="sng" algn="ctr">
-                      <a:solidFill>
-                        <a:srgbClr val="FFFFFF"/>
-                      </a:solidFill>
-                      <a:prstDash val="solid"/>
-                      <a:round/>
-                      <a:headEnd type="none" w="med" len="med"/>
-                      <a:tailEnd type="none" w="med" len="med"/>
-                    </a:lnR>
-                    <a:lnT w="38100" cap="flat" cmpd="sng" algn="ctr">
-                      <a:solidFill>
-                        <a:srgbClr val="FFFFFF"/>
-                      </a:solidFill>
-                      <a:prstDash val="solid"/>
-                      <a:round/>
-                      <a:headEnd type="none" w="med" len="med"/>
-                      <a:tailEnd type="none" w="med" len="med"/>
-                    </a:lnT>
-                    <a:lnB w="38100" cap="flat" cmpd="sng" algn="ctr">
-                      <a:solidFill>
-                        <a:srgbClr val="FFFFFF"/>
-                      </a:solidFill>
-                      <a:prstDash val="solid"/>
-                      <a:round/>
-                      <a:headEnd type="none" w="med" len="med"/>
-                      <a:tailEnd type="none" w="med" len="med"/>
-                    </a:lnB>
-                  </a:tcPr>
-                </a:tc>
-                <a:tc>
-                  <a:txBody>
-                    <a:bodyPr/>
-                    <a:lstStyle/>
-                    <a:p>
-                      <a:pPr indent="0" marL="0">
-                        <a:buNone/>
-                      </a:pPr>
-                      <a:r>
-                        <a:rPr lang="en-US" sz="1400" i="1" dirty="0">
-                          <a:solidFill>
-                            <a:srgbClr val="6B7280"/>
-                          </a:solidFill>
-                          <a:latin typeface="Calibri" pitchFamily="34" charset="0"/>
-                          <a:ea typeface="Calibri" pitchFamily="34" charset="-122"/>
-                          <a:cs typeface="Calibri" pitchFamily="34" charset="-120"/>
-                        </a:rPr>
-                        <a:t>drifts from the build; interrupts the agent</a:t>
-                      </a:r>
-                      <a:endParaRPr lang="en-US" sz="1400" dirty="0">
-                        <a:latin typeface="Calibri" charset="0"/>
-                        <a:ea typeface="Calibri" charset="0"/>
-                        <a:cs typeface="Calibri" charset="0"/>
-                      </a:endParaRPr>
-                    </a:p>
-                  </a:txBody>
-                  <a:tcPr marL="91440" marR="91440" marT="45720" marB="45720" anchor="ctr">
-                    <a:lnL w="38100" cap="flat" cmpd="sng" algn="ctr">
-                      <a:solidFill>
-                        <a:srgbClr val="FFFFFF"/>
-                      </a:solidFill>
-                      <a:prstDash val="solid"/>
-                      <a:round/>
-                      <a:headEnd type="none" w="med" len="med"/>
-                      <a:tailEnd type="none" w="med" len="med"/>
-                    </a:lnL>
-                    <a:lnR w="38100" cap="flat" cmpd="sng" algn="ctr">
-                      <a:solidFill>
-                        <a:srgbClr val="FFFFFF"/>
-                      </a:solidFill>
-                      <a:prstDash val="solid"/>
-                      <a:round/>
-                      <a:headEnd type="none" w="med" len="med"/>
-                      <a:tailEnd type="none" w="med" len="med"/>
-                    </a:lnR>
-                    <a:lnT w="38100" cap="flat" cmpd="sng" algn="ctr">
-                      <a:solidFill>
-                        <a:srgbClr val="FFFFFF"/>
-                      </a:solidFill>
-                      <a:prstDash val="solid"/>
-                      <a:round/>
-                      <a:headEnd type="none" w="med" len="med"/>
-                      <a:tailEnd type="none" w="med" len="med"/>
-                    </a:lnT>
-                    <a:lnB w="38100" cap="flat" cmpd="sng" algn="ctr">
-                      <a:solidFill>
-                        <a:srgbClr val="FFFFFF"/>
-                      </a:solidFill>
-                      <a:prstDash val="solid"/>
-                      <a:round/>
-                      <a:headEnd type="none" w="med" len="med"/>
-                      <a:tailEnd type="none" w="med" len="med"/>
-                    </a:lnB>
-                  </a:tcPr>
-                </a:tc>
-              </a:tr>
-              <a:tr h="731520">
-                <a:tc>
-                  <a:txBody>
-                    <a:bodyPr/>
-                    <a:lstStyle/>
-                    <a:p>
-                      <a:pPr algn="ctr" indent="0" marL="0">
-                        <a:buNone/>
-                      </a:pPr>
-                      <a:r>
-                        <a:rPr lang="en-US" sz="1500" b="1" dirty="0">
-                          <a:solidFill>
-                            <a:srgbClr val="24292F"/>
-                          </a:solidFill>
-                          <a:latin typeface="Calibri" pitchFamily="34" charset="0"/>
-                          <a:ea typeface="Calibri" pitchFamily="34" charset="-122"/>
-                          <a:cs typeface="Calibri" pitchFamily="34" charset="-120"/>
-                        </a:rPr>
-                        <a:t>now</a:t>
-                      </a:r>
-                      <a:endParaRPr lang="en-US" sz="1500" dirty="0">
-                        <a:latin typeface="Calibri" charset="0"/>
-                        <a:ea typeface="Calibri" charset="0"/>
-                        <a:cs typeface="Calibri" charset="0"/>
-                      </a:endParaRPr>
-                    </a:p>
-                  </a:txBody>
-                  <a:tcPr marL="91440" marR="91440" marT="45720" marB="45720" anchor="ctr">
-                    <a:lnL w="38100" cap="flat" cmpd="sng" algn="ctr">
-                      <a:solidFill>
-                        <a:srgbClr val="FFFFFF"/>
-                      </a:solidFill>
-                      <a:prstDash val="solid"/>
-                      <a:round/>
-                      <a:headEnd type="none" w="med" len="med"/>
-                      <a:tailEnd type="none" w="med" len="med"/>
-                    </a:lnL>
-                    <a:lnR w="38100" cap="flat" cmpd="sng" algn="ctr">
-                      <a:solidFill>
-                        <a:srgbClr val="FFFFFF"/>
-                      </a:solidFill>
-                      <a:prstDash val="solid"/>
-                      <a:round/>
-                      <a:headEnd type="none" w="med" len="med"/>
-                      <a:tailEnd type="none" w="med" len="med"/>
-                    </a:lnR>
-                    <a:lnT w="38100" cap="flat" cmpd="sng" algn="ctr">
-                      <a:solidFill>
-                        <a:srgbClr val="FFFFFF"/>
-                      </a:solidFill>
-                      <a:prstDash val="solid"/>
-                      <a:round/>
-                      <a:headEnd type="none" w="med" len="med"/>
-                      <a:tailEnd type="none" w="med" len="med"/>
-                    </a:lnT>
-                    <a:lnB w="38100" cap="flat" cmpd="sng" algn="ctr">
-                      <a:solidFill>
-                        <a:srgbClr val="FFFFFF"/>
-                      </a:solidFill>
-                      <a:prstDash val="solid"/>
-                      <a:round/>
-                      <a:headEnd type="none" w="med" len="med"/>
-                      <a:tailEnd type="none" w="med" len="med"/>
-                    </a:lnB>
-                    <a:solidFill>
-                      <a:srgbClr val="F3F4F6"/>
-                    </a:solidFill>
-                  </a:tcPr>
-                </a:tc>
-                <a:tc>
-                  <a:txBody>
-                    <a:bodyPr/>
-                    <a:lstStyle/>
-                    <a:p>
-                      <a:pPr indent="0" marL="0">
-                        <a:buNone/>
-                      </a:pPr>
-                      <a:r>
-                        <a:rPr lang="en-US" sz="1400" dirty="0">
-                          <a:solidFill>
-                            <a:srgbClr val="24292F"/>
-                          </a:solidFill>
-                          <a:latin typeface="Calibri" pitchFamily="34" charset="0"/>
-                          <a:ea typeface="Calibri" pitchFamily="34" charset="-122"/>
-                          <a:cs typeface="Calibri" pitchFamily="34" charset="-120"/>
-                        </a:rPr>
-                        <a:t>3 skills, 2 commands, 1 optional hook line</a:t>
-                      </a:r>
-                      <a:endParaRPr lang="en-US" sz="1400" dirty="0">
-                        <a:latin typeface="Calibri" charset="0"/>
-                        <a:ea typeface="Calibri" charset="0"/>
-                        <a:cs typeface="Calibri" charset="0"/>
-                      </a:endParaRPr>
-                    </a:p>
-                  </a:txBody>
-                  <a:tcPr marL="91440" marR="91440" marT="45720" marB="45720" anchor="ctr">
-                    <a:lnL w="38100" cap="flat" cmpd="sng" algn="ctr">
-                      <a:solidFill>
-                        <a:srgbClr val="FFFFFF"/>
-                      </a:solidFill>
-                      <a:prstDash val="solid"/>
-                      <a:round/>
-                      <a:headEnd type="none" w="med" len="med"/>
-                      <a:tailEnd type="none" w="med" len="med"/>
-                    </a:lnL>
-                    <a:lnR w="38100" cap="flat" cmpd="sng" algn="ctr">
-                      <a:solidFill>
-                        <a:srgbClr val="FFFFFF"/>
-                      </a:solidFill>
-                      <a:prstDash val="solid"/>
-                      <a:round/>
-                      <a:headEnd type="none" w="med" len="med"/>
-                      <a:tailEnd type="none" w="med" len="med"/>
-                    </a:lnR>
-                    <a:lnT w="38100" cap="flat" cmpd="sng" algn="ctr">
-                      <a:solidFill>
-                        <a:srgbClr val="FFFFFF"/>
-                      </a:solidFill>
-                      <a:prstDash val="solid"/>
-                      <a:round/>
-                      <a:headEnd type="none" w="med" len="med"/>
-                      <a:tailEnd type="none" w="med" len="med"/>
-                    </a:lnT>
-                    <a:lnB w="38100" cap="flat" cmpd="sng" algn="ctr">
-                      <a:solidFill>
-                        <a:srgbClr val="FFFFFF"/>
-                      </a:solidFill>
-                      <a:prstDash val="solid"/>
-                      <a:round/>
-                      <a:headEnd type="none" w="med" len="med"/>
-                      <a:tailEnd type="none" w="med" len="med"/>
-                    </a:lnB>
-                  </a:tcPr>
-                </a:tc>
-                <a:tc>
-                  <a:txBody>
-                    <a:bodyPr/>
-                    <a:lstStyle/>
-                    <a:p>
-                      <a:pPr indent="0" marL="0">
-                        <a:buNone/>
-                      </a:pPr>
-                      <a:r>
-                        <a:rPr lang="en-US" sz="1400" i="1" dirty="0">
-                          <a:solidFill>
-                            <a:srgbClr val="6B7280"/>
-                          </a:solidFill>
-                          <a:latin typeface="Calibri" pitchFamily="34" charset="0"/>
-                          <a:ea typeface="Calibri" pitchFamily="34" charset="-122"/>
-                          <a:cs typeface="Calibri" pitchFamily="34" charset="-120"/>
-                        </a:rPr>
-                        <a:t>nothing versioned against a tool or a model</a:t>
-                      </a:r>
-                      <a:endParaRPr lang="en-US" sz="1400" dirty="0">
-                        <a:latin typeface="Calibri" charset="0"/>
-                        <a:ea typeface="Calibri" charset="0"/>
-                        <a:cs typeface="Calibri" charset="0"/>
-                      </a:endParaRPr>
-                    </a:p>
-                  </a:txBody>
-                  <a:tcPr marL="91440" marR="91440" marT="45720" marB="45720" anchor="ctr">
-                    <a:lnL w="38100" cap="flat" cmpd="sng" algn="ctr">
-                      <a:solidFill>
-                        <a:srgbClr val="FFFFFF"/>
-                      </a:solidFill>
-                      <a:prstDash val="solid"/>
-                      <a:round/>
-                      <a:headEnd type="none" w="med" len="med"/>
-                      <a:tailEnd type="none" w="med" len="med"/>
-                    </a:lnL>
-                    <a:lnR w="38100" cap="flat" cmpd="sng" algn="ctr">
-                      <a:solidFill>
-                        <a:srgbClr val="FFFFFF"/>
-                      </a:solidFill>
-                      <a:prstDash val="solid"/>
-                      <a:round/>
-                      <a:headEnd type="none" w="med" len="med"/>
-                      <a:tailEnd type="none" w="med" len="med"/>
-                    </a:lnR>
-                    <a:lnT w="38100" cap="flat" cmpd="sng" algn="ctr">
-                      <a:solidFill>
-                        <a:srgbClr val="FFFFFF"/>
-                      </a:solidFill>
-                      <a:prstDash val="solid"/>
-                      <a:round/>
-                      <a:headEnd type="none" w="med" len="med"/>
-                      <a:tailEnd type="none" w="med" len="med"/>
-                    </a:lnT>
-                    <a:lnB w="38100" cap="flat" cmpd="sng" algn="ctr">
-                      <a:solidFill>
-                        <a:srgbClr val="FFFFFF"/>
-                      </a:solidFill>
-                      <a:prstDash val="solid"/>
-                      <a:round/>
-                      <a:headEnd type="none" w="med" len="med"/>
-                      <a:tailEnd type="none" w="med" len="med"/>
-                    </a:lnB>
-                  </a:tcPr>
-                </a:tc>
-              </a:tr>
-            </a:tbl>
-          </a:graphicData>
-        </a:graphic>
-      </p:graphicFrame>
-      <p:sp>
-        <p:nvSpPr>
-          <p:cNvPr id="10" name="Text 7"/>
+              <a:t>Next 50 PRs</a:t>
+            </a:r>
+            <a:endParaRPr lang="en-US" sz="2000" dirty="0"/>
+          </a:p>
+        </p:txBody>
+      </p:sp>
+      <p:sp>
+        <p:nvSpPr>
+          <p:cNvPr id="7" name="Text 5"/>
           <p:cNvSpPr txBox="1"/>
           <p:nvPr/>
         </p:nvSpPr>
         <p:spPr>
           <a:xfrm>
-            <a:off x="548640" y="5669280"/>
-            <a:ext cx="11064240" cy="457200"/>
+            <a:off x="4206240" y="2011680"/>
+            <a:ext cx="7315200" cy="914400"/>
           </a:xfrm>
           <a:prstGeom prst="rect">
             <a:avLst/>
@@ -7579,23 +6243,449 @@
               <a:buNone/>
             </a:pPr>
             <a:r>
-              <a:rPr lang="en-US" sz="1800" b="1" i="1" dirty="0">
-                <a:solidFill>
-                  <a:srgbClr val="D9480F"/>
-                </a:solidFill>
-                <a:latin typeface="Cambria" pitchFamily="34" charset="0"/>
-                <a:ea typeface="Cambria" pitchFamily="34" charset="-122"/>
-                <a:cs typeface="Cambria" pitchFamily="34" charset="-120"/>
-              </a:rPr>
-              <a:t>When the models move, we edit a paragraph — not a parser.</a:t>
-            </a:r>
-            <a:endParaRPr lang="en-US" sz="1800" dirty="0"/>
-          </a:p>
-        </p:txBody>
-      </p:sp>
-      <p:sp>
-        <p:nvSpPr>
-          <p:cNvPr id="11" name="Text 8"/>
+              <a:rPr lang="en-US" sz="1500" dirty="0">
+                <a:solidFill>
+                  <a:srgbClr val="D1D5DB"/>
+                </a:solidFill>
+                <a:latin typeface="Calibri" pitchFamily="34" charset="0"/>
+                <a:ea typeface="Calibri" pitchFamily="34" charset="-122"/>
+                <a:cs typeface="Calibri" pitchFamily="34" charset="-120"/>
+              </a:rPr>
+              <a:t>Developers run /done; the twin block lands in every PR description.</a:t>
+            </a:r>
+            <a:endParaRPr lang="en-US" sz="1500" dirty="0"/>
+          </a:p>
+        </p:txBody>
+      </p:sp>
+      <p:sp>
+        <p:nvSpPr>
+          <p:cNvPr id="8" name="Shape 6"/>
+          <p:cNvSpPr/>
+          <p:nvPr/>
+        </p:nvSpPr>
+        <p:spPr>
+          <a:xfrm>
+            <a:off x="731520" y="3081528"/>
+            <a:ext cx="502920" cy="502920"/>
+          </a:xfrm>
+          <a:prstGeom prst="ellipse">
+            <a:avLst/>
+          </a:prstGeom>
+          <a:solidFill>
+            <a:srgbClr val="D9480F"/>
+          </a:solidFill>
+          <a:ln w="12700">
+            <a:solidFill>
+              <a:srgbClr val="D9480F"/>
+            </a:solidFill>
+            <a:prstDash val="solid"/>
+          </a:ln>
+        </p:spPr>
+      </p:sp>
+      <p:sp>
+        <p:nvSpPr>
+          <p:cNvPr id="9" name="Text 7"/>
+          <p:cNvSpPr txBox="1"/>
+          <p:nvPr/>
+        </p:nvSpPr>
+        <p:spPr>
+          <a:xfrm>
+            <a:off x="731520" y="3081528"/>
+            <a:ext cx="502920" cy="502920"/>
+          </a:xfrm>
+          <a:prstGeom prst="rect">
+            <a:avLst/>
+          </a:prstGeom>
+          <a:noFill/>
+          <a:ln/>
+        </p:spPr>
+        <p:txBody>
+          <a:bodyPr wrap="square" lIns="0" tIns="0" rIns="0" bIns="0" rtlCol="0" anchor="ctr"/>
+          <a:lstStyle/>
+          <a:p>
+            <a:pPr algn="ctr" indent="0" marL="0">
+              <a:buNone/>
+            </a:pPr>
+            <a:r>
+              <a:rPr lang="en-US" sz="1600" b="1" dirty="0">
+                <a:solidFill>
+                  <a:srgbClr val="FFFFFF"/>
+                </a:solidFill>
+                <a:latin typeface="Calibri" pitchFamily="34" charset="0"/>
+                <a:ea typeface="Calibri" pitchFamily="34" charset="-122"/>
+                <a:cs typeface="Calibri" pitchFamily="34" charset="-120"/>
+              </a:rPr>
+              <a:t>2</a:t>
+            </a:r>
+            <a:endParaRPr lang="en-US" sz="1600" dirty="0"/>
+          </a:p>
+        </p:txBody>
+      </p:sp>
+      <p:sp>
+        <p:nvSpPr>
+          <p:cNvPr id="10" name="Text 8"/>
+          <p:cNvSpPr txBox="1"/>
+          <p:nvPr/>
+        </p:nvSpPr>
+        <p:spPr>
+          <a:xfrm>
+            <a:off x="1463040" y="3035808"/>
+            <a:ext cx="2743200" cy="548640"/>
+          </a:xfrm>
+          <a:prstGeom prst="rect">
+            <a:avLst/>
+          </a:prstGeom>
+          <a:noFill/>
+          <a:ln/>
+        </p:spPr>
+        <p:txBody>
+          <a:bodyPr wrap="square" lIns="0" tIns="0" rIns="0" bIns="0" rtlCol="0" anchor="ctr"/>
+          <a:lstStyle/>
+          <a:p>
+            <a:pPr indent="0" marL="0">
+              <a:buNone/>
+            </a:pPr>
+            <a:r>
+              <a:rPr lang="en-US" sz="2000" b="1" dirty="0">
+                <a:solidFill>
+                  <a:srgbClr val="FFFFFF"/>
+                </a:solidFill>
+                <a:latin typeface="Calibri" pitchFamily="34" charset="0"/>
+                <a:ea typeface="Calibri" pitchFamily="34" charset="-122"/>
+                <a:cs typeface="Calibri" pitchFamily="34" charset="-120"/>
+              </a:rPr>
+              <a:t>Calibrate first</a:t>
+            </a:r>
+            <a:endParaRPr lang="en-US" sz="2000" dirty="0"/>
+          </a:p>
+        </p:txBody>
+      </p:sp>
+      <p:sp>
+        <p:nvSpPr>
+          <p:cNvPr id="11" name="Text 9"/>
+          <p:cNvSpPr txBox="1"/>
+          <p:nvPr/>
+        </p:nvSpPr>
+        <p:spPr>
+          <a:xfrm>
+            <a:off x="4206240" y="3035808"/>
+            <a:ext cx="7315200" cy="914400"/>
+          </a:xfrm>
+          <a:prstGeom prst="rect">
+            <a:avLst/>
+          </a:prstGeom>
+          <a:noFill/>
+          <a:ln/>
+        </p:spPr>
+        <p:txBody>
+          <a:bodyPr wrap="square" lIns="0" tIns="0" rIns="0" bIns="0" rtlCol="0" anchor="ctr"/>
+          <a:lstStyle/>
+          <a:p>
+            <a:pPr indent="0" marL="0">
+              <a:buNone/>
+            </a:pPr>
+            <a:r>
+              <a:rPr lang="en-US" sz="1500" dirty="0">
+                <a:solidFill>
+                  <a:srgbClr val="D1D5DB"/>
+                </a:solidFill>
+                <a:latin typeface="Calibri" pitchFamily="34" charset="0"/>
+                <a:ea typeface="Calibri" pitchFamily="34" charset="-122"/>
+                <a:cs typeface="Calibri" pitchFamily="34" charset="-120"/>
+              </a:rPr>
+              <a:t>Run the twin on 20–30 already-merged PRs and compare with what human reviewers actually said. Answers “have you actually seen these?” with numbers.</a:t>
+            </a:r>
+            <a:endParaRPr lang="en-US" sz="1500" dirty="0"/>
+          </a:p>
+        </p:txBody>
+      </p:sp>
+      <p:sp>
+        <p:nvSpPr>
+          <p:cNvPr id="12" name="Shape 10"/>
+          <p:cNvSpPr/>
+          <p:nvPr/>
+        </p:nvSpPr>
+        <p:spPr>
+          <a:xfrm>
+            <a:off x="731520" y="4105656"/>
+            <a:ext cx="502920" cy="502920"/>
+          </a:xfrm>
+          <a:prstGeom prst="ellipse">
+            <a:avLst/>
+          </a:prstGeom>
+          <a:solidFill>
+            <a:srgbClr val="D9480F"/>
+          </a:solidFill>
+          <a:ln w="12700">
+            <a:solidFill>
+              <a:srgbClr val="D9480F"/>
+            </a:solidFill>
+            <a:prstDash val="solid"/>
+          </a:ln>
+        </p:spPr>
+      </p:sp>
+      <p:sp>
+        <p:nvSpPr>
+          <p:cNvPr id="13" name="Text 11"/>
+          <p:cNvSpPr txBox="1"/>
+          <p:nvPr/>
+        </p:nvSpPr>
+        <p:spPr>
+          <a:xfrm>
+            <a:off x="731520" y="4105656"/>
+            <a:ext cx="502920" cy="502920"/>
+          </a:xfrm>
+          <a:prstGeom prst="rect">
+            <a:avLst/>
+          </a:prstGeom>
+          <a:noFill/>
+          <a:ln/>
+        </p:spPr>
+        <p:txBody>
+          <a:bodyPr wrap="square" lIns="0" tIns="0" rIns="0" bIns="0" rtlCol="0" anchor="ctr"/>
+          <a:lstStyle/>
+          <a:p>
+            <a:pPr algn="ctr" indent="0" marL="0">
+              <a:buNone/>
+            </a:pPr>
+            <a:r>
+              <a:rPr lang="en-US" sz="1600" b="1" dirty="0">
+                <a:solidFill>
+                  <a:srgbClr val="FFFFFF"/>
+                </a:solidFill>
+                <a:latin typeface="Calibri" pitchFamily="34" charset="0"/>
+                <a:ea typeface="Calibri" pitchFamily="34" charset="-122"/>
+                <a:cs typeface="Calibri" pitchFamily="34" charset="-120"/>
+              </a:rPr>
+              <a:t>3</a:t>
+            </a:r>
+            <a:endParaRPr lang="en-US" sz="1600" dirty="0"/>
+          </a:p>
+        </p:txBody>
+      </p:sp>
+      <p:sp>
+        <p:nvSpPr>
+          <p:cNvPr id="14" name="Text 12"/>
+          <p:cNvSpPr txBox="1"/>
+          <p:nvPr/>
+        </p:nvSpPr>
+        <p:spPr>
+          <a:xfrm>
+            <a:off x="1463040" y="4059936"/>
+            <a:ext cx="2743200" cy="548640"/>
+          </a:xfrm>
+          <a:prstGeom prst="rect">
+            <a:avLst/>
+          </a:prstGeom>
+          <a:noFill/>
+          <a:ln/>
+        </p:spPr>
+        <p:txBody>
+          <a:bodyPr wrap="square" lIns="0" tIns="0" rIns="0" bIns="0" rtlCol="0" anchor="ctr"/>
+          <a:lstStyle/>
+          <a:p>
+            <a:pPr indent="0" marL="0">
+              <a:buNone/>
+            </a:pPr>
+            <a:r>
+              <a:rPr lang="en-US" sz="2000" b="1" dirty="0">
+                <a:solidFill>
+                  <a:srgbClr val="FFFFFF"/>
+                </a:solidFill>
+                <a:latin typeface="Calibri" pitchFamily="34" charset="0"/>
+                <a:ea typeface="Calibri" pitchFamily="34" charset="-122"/>
+                <a:cs typeface="Calibri" pitchFamily="34" charset="-120"/>
+              </a:rPr>
+              <a:t>Measure</a:t>
+            </a:r>
+            <a:endParaRPr lang="en-US" sz="2000" dirty="0"/>
+          </a:p>
+        </p:txBody>
+      </p:sp>
+      <p:sp>
+        <p:nvSpPr>
+          <p:cNvPr id="15" name="Text 13"/>
+          <p:cNvSpPr txBox="1"/>
+          <p:nvPr/>
+        </p:nvSpPr>
+        <p:spPr>
+          <a:xfrm>
+            <a:off x="4206240" y="4059936"/>
+            <a:ext cx="7315200" cy="914400"/>
+          </a:xfrm>
+          <a:prstGeom prst="rect">
+            <a:avLst/>
+          </a:prstGeom>
+          <a:noFill/>
+          <a:ln/>
+        </p:spPr>
+        <p:txBody>
+          <a:bodyPr wrap="square" lIns="0" tIns="0" rIns="0" bIns="0" rtlCol="0" anchor="ctr"/>
+          <a:lstStyle/>
+          <a:p>
+            <a:pPr indent="0" marL="0">
+              <a:buNone/>
+            </a:pPr>
+            <a:r>
+              <a:rPr lang="en-US" sz="1500" dirty="0">
+                <a:solidFill>
+                  <a:srgbClr val="D1D5DB"/>
+                </a:solidFill>
+                <a:latin typeface="Calibri" pitchFamily="34" charset="0"/>
+                <a:ea typeface="Calibri" pitchFamily="34" charset="-122"/>
+                <a:cs typeface="Calibri" pitchFamily="34" charset="-120"/>
+              </a:rPr>
+              <a:t>Median verbosity ratio of merged PRs, tracked for one quarter.</a:t>
+            </a:r>
+            <a:endParaRPr lang="en-US" sz="1500" dirty="0"/>
+          </a:p>
+        </p:txBody>
+      </p:sp>
+      <p:sp>
+        <p:nvSpPr>
+          <p:cNvPr id="16" name="Shape 14"/>
+          <p:cNvSpPr/>
+          <p:nvPr/>
+        </p:nvSpPr>
+        <p:spPr>
+          <a:xfrm>
+            <a:off x="731520" y="5129784"/>
+            <a:ext cx="502920" cy="502920"/>
+          </a:xfrm>
+          <a:prstGeom prst="ellipse">
+            <a:avLst/>
+          </a:prstGeom>
+          <a:solidFill>
+            <a:srgbClr val="D9480F"/>
+          </a:solidFill>
+          <a:ln w="12700">
+            <a:solidFill>
+              <a:srgbClr val="D9480F"/>
+            </a:solidFill>
+            <a:prstDash val="solid"/>
+          </a:ln>
+        </p:spPr>
+      </p:sp>
+      <p:sp>
+        <p:nvSpPr>
+          <p:cNvPr id="17" name="Text 15"/>
+          <p:cNvSpPr txBox="1"/>
+          <p:nvPr/>
+        </p:nvSpPr>
+        <p:spPr>
+          <a:xfrm>
+            <a:off x="731520" y="5129784"/>
+            <a:ext cx="502920" cy="502920"/>
+          </a:xfrm>
+          <a:prstGeom prst="rect">
+            <a:avLst/>
+          </a:prstGeom>
+          <a:noFill/>
+          <a:ln/>
+        </p:spPr>
+        <p:txBody>
+          <a:bodyPr wrap="square" lIns="0" tIns="0" rIns="0" bIns="0" rtlCol="0" anchor="ctr"/>
+          <a:lstStyle/>
+          <a:p>
+            <a:pPr algn="ctr" indent="0" marL="0">
+              <a:buNone/>
+            </a:pPr>
+            <a:r>
+              <a:rPr lang="en-US" sz="1600" b="1" dirty="0">
+                <a:solidFill>
+                  <a:srgbClr val="FFFFFF"/>
+                </a:solidFill>
+                <a:latin typeface="Calibri" pitchFamily="34" charset="0"/>
+                <a:ea typeface="Calibri" pitchFamily="34" charset="-122"/>
+                <a:cs typeface="Calibri" pitchFamily="34" charset="-120"/>
+              </a:rPr>
+              <a:t>4</a:t>
+            </a:r>
+            <a:endParaRPr lang="en-US" sz="1600" dirty="0"/>
+          </a:p>
+        </p:txBody>
+      </p:sp>
+      <p:sp>
+        <p:nvSpPr>
+          <p:cNvPr id="18" name="Text 16"/>
+          <p:cNvSpPr txBox="1"/>
+          <p:nvPr/>
+        </p:nvSpPr>
+        <p:spPr>
+          <a:xfrm>
+            <a:off x="1463040" y="5084064"/>
+            <a:ext cx="2743200" cy="548640"/>
+          </a:xfrm>
+          <a:prstGeom prst="rect">
+            <a:avLst/>
+          </a:prstGeom>
+          <a:noFill/>
+          <a:ln/>
+        </p:spPr>
+        <p:txBody>
+          <a:bodyPr wrap="square" lIns="0" tIns="0" rIns="0" bIns="0" rtlCol="0" anchor="ctr"/>
+          <a:lstStyle/>
+          <a:p>
+            <a:pPr indent="0" marL="0">
+              <a:buNone/>
+            </a:pPr>
+            <a:r>
+              <a:rPr lang="en-US" sz="2000" b="1" dirty="0">
+                <a:solidFill>
+                  <a:srgbClr val="FFFFFF"/>
+                </a:solidFill>
+                <a:latin typeface="Calibri" pitchFamily="34" charset="0"/>
+                <a:ea typeface="Calibri" pitchFamily="34" charset="-122"/>
+                <a:cs typeface="Calibri" pitchFamily="34" charset="-120"/>
+              </a:rPr>
+              <a:t>Decide</a:t>
+            </a:r>
+            <a:endParaRPr lang="en-US" sz="2000" dirty="0"/>
+          </a:p>
+        </p:txBody>
+      </p:sp>
+      <p:sp>
+        <p:nvSpPr>
+          <p:cNvPr id="19" name="Text 17"/>
+          <p:cNvSpPr txBox="1"/>
+          <p:nvPr/>
+        </p:nvSpPr>
+        <p:spPr>
+          <a:xfrm>
+            <a:off x="4206240" y="5084064"/>
+            <a:ext cx="7315200" cy="914400"/>
+          </a:xfrm>
+          <a:prstGeom prst="rect">
+            <a:avLst/>
+          </a:prstGeom>
+          <a:noFill/>
+          <a:ln/>
+        </p:spPr>
+        <p:txBody>
+          <a:bodyPr wrap="square" lIns="0" tIns="0" rIns="0" bIns="0" rtlCol="0" anchor="ctr"/>
+          <a:lstStyle/>
+          <a:p>
+            <a:pPr indent="0" marL="0">
+              <a:buNone/>
+            </a:pPr>
+            <a:r>
+              <a:rPr lang="en-US" sz="1500" dirty="0">
+                <a:solidFill>
+                  <a:srgbClr val="D1D5DB"/>
+                </a:solidFill>
+                <a:latin typeface="Calibri" pitchFamily="34" charset="0"/>
+                <a:ea typeface="Calibri" pitchFamily="34" charset="-122"/>
+                <a:cs typeface="Calibri" pitchFamily="34" charset="-120"/>
+              </a:rPr>
+              <a:t>If the median drops: wire the PR-agent paragraph in and call it a standard. If it doesn't: delete the pack. Re-run the calibration set after any model change — it is the regression test.</a:t>
+            </a:r>
+            <a:endParaRPr lang="en-US" sz="1500" dirty="0"/>
+          </a:p>
+        </p:txBody>
+      </p:sp>
+      <p:sp>
+        <p:nvSpPr>
+          <p:cNvPr id="20" name="Text 18"/>
           <p:cNvSpPr txBox="1"/>
           <p:nvPr/>
         </p:nvSpPr>
@@ -7620,7 +6710,7 @@
             <a:r>
               <a:rPr lang="en-US" sz="1000" dirty="0">
                 <a:solidFill>
-                  <a:srgbClr val="6B7280"/>
+                  <a:srgbClr val="9CA3AF"/>
                 </a:solidFill>
                 <a:latin typeface="Calibri" pitchFamily="34" charset="0"/>
                 <a:ea typeface="Calibri" pitchFamily="34" charset="-122"/>

</xml_diff>